<commit_message>
fix(investor): §45b auf 131€ korrigiert + echtes AlltagsEngel-Logo im Pitch Deck
</commit_message>
<xml_diff>
--- a/investor/AlltagsEngel_PitchDeck_2026.pptx
+++ b/investor/AlltagsEngel_PitchDeck_2026.pptx
@@ -2513,7 +2513,7 @@
       </p:sp>
       <p:pic>
         <p:nvPicPr>
-          <p:cNvPr id="6" name="Image 0" descr="preencoded.png">    </p:cNvPr>
+          <p:cNvPr id="6" name="Image 0" descr="logo-mark.png">    </p:cNvPr>
           <p:cNvPicPr>
             <a:picLocks noChangeAspect="1"/>
           </p:cNvPicPr>
@@ -2527,8 +2527,8 @@
         </p:blipFill>
         <p:spPr>
           <a:xfrm>
-            <a:off x="731520" y="1371600"/>
-            <a:ext cx="731520" cy="731520"/>
+            <a:off x="731520" y="1280160"/>
+            <a:ext cx="1463040" cy="804672"/>
           </a:xfrm>
           <a:prstGeom prst="rect">
             <a:avLst/>
@@ -2543,7 +2543,7 @@
         </p:nvSpPr>
         <p:spPr>
           <a:xfrm>
-            <a:off x="731520" y="2194560"/>
+            <a:off x="731520" y="2286000"/>
             <a:ext cx="10972800" cy="1280160"/>
           </a:xfrm>
           <a:prstGeom prst="rect">
@@ -7219,146 +7219,9 @@
           <a:ln/>
         </p:spPr>
       </p:sp>
-      <p:sp>
-        <p:nvSpPr>
-          <p:cNvPr id="5" name="Text 3"/>
-          <p:cNvSpPr/>
-          <p:nvPr/>
-        </p:nvSpPr>
-        <p:spPr>
-          <a:xfrm>
-            <a:off x="731520" y="914400"/>
-            <a:ext cx="10972800" cy="1097280"/>
-          </a:xfrm>
-          <a:prstGeom prst="rect">
-            <a:avLst/>
-          </a:prstGeom>
-          <a:noFill/>
-          <a:ln/>
-        </p:spPr>
-        <p:txBody>
-          <a:bodyPr wrap="square" lIns="0" tIns="0" rIns="0" bIns="0" rtlCol="0" anchor="ctr"/>
-          <a:lstStyle/>
-          <a:p>
-            <a:pPr indent="0" marL="0">
-              <a:buNone/>
-            </a:pPr>
-            <a:r>
-              <a:rPr lang="en-US" sz="8000" i="1" dirty="0">
-                <a:solidFill>
-                  <a:srgbClr val="F5EFE6"/>
-                </a:solidFill>
-                <a:latin typeface="Georgia" pitchFamily="34" charset="0"/>
-                <a:ea typeface="Georgia" pitchFamily="34" charset="-122"/>
-                <a:cs typeface="Georgia" pitchFamily="34" charset="-120"/>
-              </a:rPr>
-              <a:t>DANKE.</a:t>
-            </a:r>
-            <a:endParaRPr lang="en-US" sz="8000" dirty="0"/>
-          </a:p>
-        </p:txBody>
-      </p:sp>
-      <p:sp>
-        <p:nvSpPr>
-          <p:cNvPr id="6" name="Text 4"/>
-          <p:cNvSpPr/>
-          <p:nvPr/>
-        </p:nvSpPr>
-        <p:spPr>
-          <a:xfrm>
-            <a:off x="731520" y="2194560"/>
-            <a:ext cx="10972800" cy="640080"/>
-          </a:xfrm>
-          <a:prstGeom prst="rect">
-            <a:avLst/>
-          </a:prstGeom>
-          <a:noFill/>
-          <a:ln/>
-        </p:spPr>
-        <p:txBody>
-          <a:bodyPr wrap="square" lIns="0" tIns="0" rIns="0" bIns="0" rtlCol="0" anchor="ctr"/>
-          <a:lstStyle/>
-          <a:p>
-            <a:pPr indent="0" marL="0">
-              <a:buNone/>
-            </a:pPr>
-            <a:r>
-              <a:rPr lang="en-US" sz="2800" i="1" dirty="0">
-                <a:solidFill>
-                  <a:srgbClr val="E0C687"/>
-                </a:solidFill>
-                <a:latin typeface="Georgia" pitchFamily="34" charset="0"/>
-                <a:ea typeface="Georgia" pitchFamily="34" charset="-122"/>
-                <a:cs typeface="Georgia" pitchFamily="34" charset="-120"/>
-              </a:rPr>
-              <a:t>Lass uns die Pflege in Deutschland neu bauen.</a:t>
-            </a:r>
-            <a:endParaRPr lang="en-US" sz="2800" dirty="0"/>
-          </a:p>
-        </p:txBody>
-      </p:sp>
-      <p:sp>
-        <p:nvSpPr>
-          <p:cNvPr id="7" name="Shape 5"/>
-          <p:cNvSpPr/>
-          <p:nvPr/>
-        </p:nvSpPr>
-        <p:spPr>
-          <a:xfrm>
-            <a:off x="731520" y="3063240"/>
-            <a:ext cx="457200" cy="27432"/>
-          </a:xfrm>
-          <a:prstGeom prst="rect">
-            <a:avLst/>
-          </a:prstGeom>
-          <a:solidFill>
-            <a:srgbClr val="C9A24B"/>
-          </a:solidFill>
-          <a:ln/>
-        </p:spPr>
-      </p:sp>
-      <p:sp>
-        <p:nvSpPr>
-          <p:cNvPr id="8" name="Text 6"/>
-          <p:cNvSpPr/>
-          <p:nvPr/>
-        </p:nvSpPr>
-        <p:spPr>
-          <a:xfrm>
-            <a:off x="731520" y="3246120"/>
-            <a:ext cx="7315200" cy="274320"/>
-          </a:xfrm>
-          <a:prstGeom prst="rect">
-            <a:avLst/>
-          </a:prstGeom>
-          <a:noFill/>
-          <a:ln/>
-        </p:spPr>
-        <p:txBody>
-          <a:bodyPr wrap="square" lIns="0" tIns="0" rIns="0" bIns="0" rtlCol="0" anchor="ctr"/>
-          <a:lstStyle/>
-          <a:p>
-            <a:pPr indent="0" marL="0">
-              <a:buNone/>
-            </a:pPr>
-            <a:r>
-              <a:rPr lang="en-US" sz="1100" b="1" spc="600" kern="0" dirty="0">
-                <a:solidFill>
-                  <a:srgbClr val="C9A24B"/>
-                </a:solidFill>
-                <a:latin typeface="Calibri" pitchFamily="34" charset="0"/>
-                <a:ea typeface="Calibri" pitchFamily="34" charset="-122"/>
-                <a:cs typeface="Calibri" pitchFamily="34" charset="-120"/>
-              </a:rPr>
-              <a:t>KONTAKT</a:t>
-            </a:r>
-            <a:endParaRPr lang="en-US" sz="1100" dirty="0"/>
-          </a:p>
-        </p:txBody>
-      </p:sp>
       <p:pic>
         <p:nvPicPr>
-          <p:cNvPr id="9" name="Image 0" descr="preencoded.png">    </p:cNvPr>
+          <p:cNvPr id="5" name="Image 0" descr="logo-mark.png">    </p:cNvPr>
           <p:cNvPicPr>
             <a:picLocks noChangeAspect="1"/>
           </p:cNvPicPr>
@@ -7372,8 +7235,8 @@
         </p:blipFill>
         <p:spPr>
           <a:xfrm>
-            <a:off x="731520" y="3685032"/>
-            <a:ext cx="274320" cy="274320"/>
+            <a:off x="10545775" y="457200"/>
+            <a:ext cx="914400" cy="502920"/>
           </a:xfrm>
           <a:prstGeom prst="rect">
             <a:avLst/>
@@ -7382,14 +7245,14 @@
       </p:pic>
       <p:sp>
         <p:nvSpPr>
-          <p:cNvPr id="10" name="Text 7"/>
-          <p:cNvSpPr/>
-          <p:nvPr/>
-        </p:nvSpPr>
-        <p:spPr>
-          <a:xfrm>
-            <a:off x="1143000" y="3657600"/>
-            <a:ext cx="10058400" cy="365760"/>
+          <p:cNvPr id="6" name="Text 3"/>
+          <p:cNvSpPr/>
+          <p:nvPr/>
+        </p:nvSpPr>
+        <p:spPr>
+          <a:xfrm>
+            <a:off x="731520" y="914400"/>
+            <a:ext cx="10972800" cy="1097280"/>
           </a:xfrm>
           <a:prstGeom prst="rect">
             <a:avLst/>
@@ -7405,23 +7268,121 @@
               <a:buNone/>
             </a:pPr>
             <a:r>
-              <a:rPr lang="en-US" sz="1400" dirty="0">
+              <a:rPr lang="en-US" sz="8000" i="1" dirty="0">
                 <a:solidFill>
                   <a:srgbClr val="F5EFE6"/>
                 </a:solidFill>
-                <a:latin typeface="Calibri" pitchFamily="34" charset="0"/>
-                <a:ea typeface="Calibri" pitchFamily="34" charset="-122"/>
-                <a:cs typeface="Calibri" pitchFamily="34" charset="-120"/>
-              </a:rPr>
-              <a:t>Yusuf Cilcioglu — Gründer &amp; CEO</a:t>
-            </a:r>
-            <a:endParaRPr lang="en-US" sz="1400" dirty="0"/>
+                <a:latin typeface="Georgia" pitchFamily="34" charset="0"/>
+                <a:ea typeface="Georgia" pitchFamily="34" charset="-122"/>
+                <a:cs typeface="Georgia" pitchFamily="34" charset="-120"/>
+              </a:rPr>
+              <a:t>DANKE.</a:t>
+            </a:r>
+            <a:endParaRPr lang="en-US" sz="8000" dirty="0"/>
+          </a:p>
+        </p:txBody>
+      </p:sp>
+      <p:sp>
+        <p:nvSpPr>
+          <p:cNvPr id="7" name="Text 4"/>
+          <p:cNvSpPr/>
+          <p:nvPr/>
+        </p:nvSpPr>
+        <p:spPr>
+          <a:xfrm>
+            <a:off x="731520" y="2194560"/>
+            <a:ext cx="10972800" cy="640080"/>
+          </a:xfrm>
+          <a:prstGeom prst="rect">
+            <a:avLst/>
+          </a:prstGeom>
+          <a:noFill/>
+          <a:ln/>
+        </p:spPr>
+        <p:txBody>
+          <a:bodyPr wrap="square" lIns="0" tIns="0" rIns="0" bIns="0" rtlCol="0" anchor="ctr"/>
+          <a:lstStyle/>
+          <a:p>
+            <a:pPr indent="0" marL="0">
+              <a:buNone/>
+            </a:pPr>
+            <a:r>
+              <a:rPr lang="en-US" sz="2800" i="1" dirty="0">
+                <a:solidFill>
+                  <a:srgbClr val="E0C687"/>
+                </a:solidFill>
+                <a:latin typeface="Georgia" pitchFamily="34" charset="0"/>
+                <a:ea typeface="Georgia" pitchFamily="34" charset="-122"/>
+                <a:cs typeface="Georgia" pitchFamily="34" charset="-120"/>
+              </a:rPr>
+              <a:t>Lass uns die Pflege in Deutschland neu bauen.</a:t>
+            </a:r>
+            <a:endParaRPr lang="en-US" sz="2800" dirty="0"/>
+          </a:p>
+        </p:txBody>
+      </p:sp>
+      <p:sp>
+        <p:nvSpPr>
+          <p:cNvPr id="8" name="Shape 5"/>
+          <p:cNvSpPr/>
+          <p:nvPr/>
+        </p:nvSpPr>
+        <p:spPr>
+          <a:xfrm>
+            <a:off x="731520" y="3063240"/>
+            <a:ext cx="457200" cy="27432"/>
+          </a:xfrm>
+          <a:prstGeom prst="rect">
+            <a:avLst/>
+          </a:prstGeom>
+          <a:solidFill>
+            <a:srgbClr val="C9A24B"/>
+          </a:solidFill>
+          <a:ln/>
+        </p:spPr>
+      </p:sp>
+      <p:sp>
+        <p:nvSpPr>
+          <p:cNvPr id="9" name="Text 6"/>
+          <p:cNvSpPr/>
+          <p:nvPr/>
+        </p:nvSpPr>
+        <p:spPr>
+          <a:xfrm>
+            <a:off x="731520" y="3246120"/>
+            <a:ext cx="7315200" cy="274320"/>
+          </a:xfrm>
+          <a:prstGeom prst="rect">
+            <a:avLst/>
+          </a:prstGeom>
+          <a:noFill/>
+          <a:ln/>
+        </p:spPr>
+        <p:txBody>
+          <a:bodyPr wrap="square" lIns="0" tIns="0" rIns="0" bIns="0" rtlCol="0" anchor="ctr"/>
+          <a:lstStyle/>
+          <a:p>
+            <a:pPr indent="0" marL="0">
+              <a:buNone/>
+            </a:pPr>
+            <a:r>
+              <a:rPr lang="en-US" sz="1100" b="1" spc="600" kern="0" dirty="0">
+                <a:solidFill>
+                  <a:srgbClr val="C9A24B"/>
+                </a:solidFill>
+                <a:latin typeface="Calibri" pitchFamily="34" charset="0"/>
+                <a:ea typeface="Calibri" pitchFamily="34" charset="-122"/>
+                <a:cs typeface="Calibri" pitchFamily="34" charset="-120"/>
+              </a:rPr>
+              <a:t>KONTAKT</a:t>
+            </a:r>
+            <a:endParaRPr lang="en-US" sz="1100" dirty="0"/>
           </a:p>
         </p:txBody>
       </p:sp>
       <p:pic>
         <p:nvPicPr>
-          <p:cNvPr id="11" name="Image 1" descr="preencoded.png">    </p:cNvPr>
+          <p:cNvPr id="10" name="Image 1" descr="preencoded.png">    </p:cNvPr>
           <p:cNvPicPr>
             <a:picLocks noChangeAspect="1"/>
           </p:cNvPicPr>
@@ -7435,7 +7396,7 @@
         </p:blipFill>
         <p:spPr>
           <a:xfrm>
-            <a:off x="731520" y="4096512"/>
+            <a:off x="731520" y="3685032"/>
             <a:ext cx="274320" cy="274320"/>
           </a:xfrm>
           <a:prstGeom prst="rect">
@@ -7445,13 +7406,13 @@
       </p:pic>
       <p:sp>
         <p:nvSpPr>
-          <p:cNvPr id="12" name="Text 8"/>
-          <p:cNvSpPr/>
-          <p:nvPr/>
-        </p:nvSpPr>
-        <p:spPr>
-          <a:xfrm>
-            <a:off x="1143000" y="4069080"/>
+          <p:cNvPr id="11" name="Text 7"/>
+          <p:cNvSpPr/>
+          <p:nvPr/>
+        </p:nvSpPr>
+        <p:spPr>
+          <a:xfrm>
+            <a:off x="1143000" y="3657600"/>
             <a:ext cx="10058400" cy="365760"/>
           </a:xfrm>
           <a:prstGeom prst="rect">
@@ -7476,7 +7437,7 @@
                 <a:ea typeface="Calibri" pitchFamily="34" charset="-122"/>
                 <a:cs typeface="Calibri" pitchFamily="34" charset="-120"/>
               </a:rPr>
-              <a:t>+49 178 338 2825</a:t>
+              <a:t>Yusuf Cilcioglu — Gründer &amp; CEO</a:t>
             </a:r>
             <a:endParaRPr lang="en-US" sz="1400" dirty="0"/>
           </a:p>
@@ -7484,7 +7445,7 @@
       </p:sp>
       <p:pic>
         <p:nvPicPr>
-          <p:cNvPr id="13" name="Image 2" descr="preencoded.png">    </p:cNvPr>
+          <p:cNvPr id="12" name="Image 2" descr="preencoded.png">    </p:cNvPr>
           <p:cNvPicPr>
             <a:picLocks noChangeAspect="1"/>
           </p:cNvPicPr>
@@ -7498,7 +7459,7 @@
         </p:blipFill>
         <p:spPr>
           <a:xfrm>
-            <a:off x="731520" y="4507992"/>
+            <a:off x="731520" y="4096512"/>
             <a:ext cx="274320" cy="274320"/>
           </a:xfrm>
           <a:prstGeom prst="rect">
@@ -7508,13 +7469,13 @@
       </p:pic>
       <p:sp>
         <p:nvSpPr>
-          <p:cNvPr id="14" name="Text 9"/>
-          <p:cNvSpPr/>
-          <p:nvPr/>
-        </p:nvSpPr>
-        <p:spPr>
-          <a:xfrm>
-            <a:off x="1143000" y="4480560"/>
+          <p:cNvPr id="13" name="Text 8"/>
+          <p:cNvSpPr/>
+          <p:nvPr/>
+        </p:nvSpPr>
+        <p:spPr>
+          <a:xfrm>
+            <a:off x="1143000" y="4069080"/>
             <a:ext cx="10058400" cy="365760"/>
           </a:xfrm>
           <a:prstGeom prst="rect">
@@ -7539,7 +7500,7 @@
                 <a:ea typeface="Calibri" pitchFamily="34" charset="-122"/>
                 <a:cs typeface="Calibri" pitchFamily="34" charset="-120"/>
               </a:rPr>
-              <a:t>y.cilcioglu@googlemail.com</a:t>
+              <a:t>+49 178 338 2825</a:t>
             </a:r>
             <a:endParaRPr lang="en-US" sz="1400" dirty="0"/>
           </a:p>
@@ -7547,7 +7508,7 @@
       </p:sp>
       <p:pic>
         <p:nvPicPr>
-          <p:cNvPr id="15" name="Image 3" descr="preencoded.png">    </p:cNvPr>
+          <p:cNvPr id="14" name="Image 3" descr="preencoded.png">    </p:cNvPr>
           <p:cNvPicPr>
             <a:picLocks noChangeAspect="1"/>
           </p:cNvPicPr>
@@ -7561,7 +7522,7 @@
         </p:blipFill>
         <p:spPr>
           <a:xfrm>
-            <a:off x="731520" y="4919472"/>
+            <a:off x="731520" y="4507992"/>
             <a:ext cx="274320" cy="274320"/>
           </a:xfrm>
           <a:prstGeom prst="rect">
@@ -7571,13 +7532,13 @@
       </p:pic>
       <p:sp>
         <p:nvSpPr>
-          <p:cNvPr id="16" name="Text 10"/>
-          <p:cNvSpPr/>
-          <p:nvPr/>
-        </p:nvSpPr>
-        <p:spPr>
-          <a:xfrm>
-            <a:off x="1143000" y="4892040"/>
+          <p:cNvPr id="15" name="Text 9"/>
+          <p:cNvSpPr/>
+          <p:nvPr/>
+        </p:nvSpPr>
+        <p:spPr>
+          <a:xfrm>
+            <a:off x="1143000" y="4480560"/>
             <a:ext cx="10058400" cy="365760"/>
           </a:xfrm>
           <a:prstGeom prst="rect">
@@ -7602,7 +7563,7 @@
                 <a:ea typeface="Calibri" pitchFamily="34" charset="-122"/>
                 <a:cs typeface="Calibri" pitchFamily="34" charset="-120"/>
               </a:rPr>
-              <a:t>AlltagsEngel UG (i.G.) · Frankfurt am Main</a:t>
+              <a:t>y.cilcioglu@googlemail.com</a:t>
             </a:r>
             <a:endParaRPr lang="en-US" sz="1400" dirty="0"/>
           </a:p>
@@ -7610,7 +7571,7 @@
       </p:sp>
       <p:pic>
         <p:nvPicPr>
-          <p:cNvPr id="17" name="Image 4" descr="preencoded.png">    </p:cNvPr>
+          <p:cNvPr id="16" name="Image 4" descr="preencoded.png">    </p:cNvPr>
           <p:cNvPicPr>
             <a:picLocks noChangeAspect="1"/>
           </p:cNvPicPr>
@@ -7624,6 +7585,69 @@
         </p:blipFill>
         <p:spPr>
           <a:xfrm>
+            <a:off x="731520" y="4919472"/>
+            <a:ext cx="274320" cy="274320"/>
+          </a:xfrm>
+          <a:prstGeom prst="rect">
+            <a:avLst/>
+          </a:prstGeom>
+        </p:spPr>
+      </p:pic>
+      <p:sp>
+        <p:nvSpPr>
+          <p:cNvPr id="17" name="Text 10"/>
+          <p:cNvSpPr/>
+          <p:nvPr/>
+        </p:nvSpPr>
+        <p:spPr>
+          <a:xfrm>
+            <a:off x="1143000" y="4892040"/>
+            <a:ext cx="10058400" cy="365760"/>
+          </a:xfrm>
+          <a:prstGeom prst="rect">
+            <a:avLst/>
+          </a:prstGeom>
+          <a:noFill/>
+          <a:ln/>
+        </p:spPr>
+        <p:txBody>
+          <a:bodyPr wrap="square" lIns="0" tIns="0" rIns="0" bIns="0" rtlCol="0" anchor="ctr"/>
+          <a:lstStyle/>
+          <a:p>
+            <a:pPr indent="0" marL="0">
+              <a:buNone/>
+            </a:pPr>
+            <a:r>
+              <a:rPr lang="en-US" sz="1400" dirty="0">
+                <a:solidFill>
+                  <a:srgbClr val="F5EFE6"/>
+                </a:solidFill>
+                <a:latin typeface="Calibri" pitchFamily="34" charset="0"/>
+                <a:ea typeface="Calibri" pitchFamily="34" charset="-122"/>
+                <a:cs typeface="Calibri" pitchFamily="34" charset="-120"/>
+              </a:rPr>
+              <a:t>AlltagsEngel UG (i.G.) · Frankfurt am Main</a:t>
+            </a:r>
+            <a:endParaRPr lang="en-US" sz="1400" dirty="0"/>
+          </a:p>
+        </p:txBody>
+      </p:sp>
+      <p:pic>
+        <p:nvPicPr>
+          <p:cNvPr id="18" name="Image 5" descr="preencoded.png">    </p:cNvPr>
+          <p:cNvPicPr>
+            <a:picLocks noChangeAspect="1"/>
+          </p:cNvPicPr>
+          <p:nvPr/>
+        </p:nvPicPr>
+        <p:blipFill>
+          <a:blip r:embed="rId6"/>
+          <a:stretch>
+            <a:fillRect/>
+          </a:stretch>
+        </p:blipFill>
+        <p:spPr>
+          <a:xfrm>
             <a:off x="731520" y="5330952"/>
             <a:ext cx="274320" cy="274320"/>
           </a:xfrm>
@@ -7634,7 +7658,7 @@
       </p:pic>
       <p:sp>
         <p:nvSpPr>
-          <p:cNvPr id="18" name="Text 11"/>
+          <p:cNvPr id="19" name="Text 11"/>
           <p:cNvSpPr/>
           <p:nvPr/>
         </p:nvSpPr>
@@ -7673,7 +7697,7 @@
       </p:sp>
       <p:sp>
         <p:nvSpPr>
-          <p:cNvPr id="19" name="Text 12"/>
+          <p:cNvPr id="20" name="Text 12"/>
           <p:cNvSpPr/>
           <p:nvPr/>
         </p:nvSpPr>
@@ -7814,7 +7838,7 @@
                 <a:ea typeface="Georgia" pitchFamily="34" charset="-122"/>
                 <a:cs typeface="Georgia" pitchFamily="34" charset="-120"/>
               </a:rPr>
-              <a:t>125 € im Monat. Jeden Monat. Ungenutzt.</a:t>
+              <a:t>131 € im Monat. Jeden Monat. Ungenutzt.</a:t>
             </a:r>
             <a:endParaRPr lang="en-US" sz="3800" dirty="0"/>
           </a:p>

</xml_diff>

<commit_message>
fix(investor): Gründer-Name korrigiert auf Yusuf Ferhat Demir (alle 4 Deliverables)
</commit_message>
<xml_diff>
--- a/investor/AlltagsEngel_PitchDeck_2026.pptx
+++ b/investor/AlltagsEngel_PitchDeck_2026.pptx
@@ -2705,7 +2705,7 @@
                 <a:ea typeface="Calibri" pitchFamily="34" charset="-122"/>
                 <a:cs typeface="Calibri" pitchFamily="34" charset="-120"/>
               </a:rPr>
-              <a:t>Yusuf Cilcioglu</a:t>
+              <a:t>Yusuf Ferhat Demir</a:t>
             </a:r>
             <a:endParaRPr lang="en-US" sz="1400" dirty="0"/>
           </a:p>
@@ -2986,7 +2986,7 @@
                 <a:ea typeface="Georgia" pitchFamily="34" charset="-122"/>
                 <a:cs typeface="Georgia" pitchFamily="34" charset="-120"/>
               </a:rPr>
-              <a:t>Yusuf Cilcioglu</a:t>
+              <a:t>Yusuf Ferhat Demir</a:t>
             </a:r>
             <a:endParaRPr lang="en-US" sz="2400" dirty="0"/>
           </a:p>
@@ -7437,7 +7437,7 @@
                 <a:ea typeface="Calibri" pitchFamily="34" charset="-122"/>
                 <a:cs typeface="Calibri" pitchFamily="34" charset="-120"/>
               </a:rPr>
-              <a:t>Yusuf Cilcioglu — Gründer &amp; CEO</a:t>
+              <a:t>Yusuf Ferhat Demir — Gründer &amp; CEO</a:t>
             </a:r>
             <a:endParaRPr lang="en-US" sz="1400" dirty="0"/>
           </a:p>

</xml_diff>

<commit_message>
Investor-Paket v2: detaillierter Use-of-Funds (10 Positionen)
- Gründer-Gehalt 6 T€/Mon (108 T€ · 10,8%)
- Firmenwagen Leasing 18 T€ (1,8%)
- Büro/Co-Working FFM+NRW 22 T€ (2,2%)
- Recht/Notar/Versicherung/Steuerberater 32 T€ (3,2%)
- Team 4 Hires gestaffelt 380 T€ (38%)
- Marketing 220 T€ · Expansion NRW 110 T€ · Tech 60 T€ · Puffer 50 T€

Businessplan, Pitch Deck (Slide 12), One-Pager und Finanzmodell
konsistent aufeinander abgestimmt. Personalplan-Tabelle mit 5 Hires
+ Freelancer-Puffer ergänzt. P&L und Sensitivität aktualisiert.
</commit_message>
<xml_diff>
--- a/investor/AlltagsEngel_PitchDeck_2026.pptx
+++ b/investor/AlltagsEngel_PitchDeck_2026.pptx
@@ -5008,8 +5008,8 @@
         </p:nvSpPr>
         <p:spPr>
           <a:xfrm>
-            <a:off x="731520" y="3611880"/>
-            <a:ext cx="2651760" cy="2103120"/>
+            <a:off x="731520" y="3474720"/>
+            <a:ext cx="2157984" cy="1965960"/>
           </a:xfrm>
           <a:prstGeom prst="rect">
             <a:avLst/>
@@ -5041,8 +5041,8 @@
         </p:blipFill>
         <p:spPr>
           <a:xfrm>
-            <a:off x="1783080" y="3886200"/>
-            <a:ext cx="548640" cy="548640"/>
+            <a:off x="1572768" y="3675888"/>
+            <a:ext cx="475488" cy="475488"/>
           </a:xfrm>
           <a:prstGeom prst="rect">
             <a:avLst/>
@@ -5057,8 +5057,8 @@
         </p:nvSpPr>
         <p:spPr>
           <a:xfrm>
-            <a:off x="731520" y="4526280"/>
-            <a:ext cx="2651760" cy="548640"/>
+            <a:off x="731520" y="4251960"/>
+            <a:ext cx="2157984" cy="502920"/>
           </a:xfrm>
           <a:prstGeom prst="rect">
             <a:avLst/>
@@ -5074,7 +5074,7 @@
               <a:buNone/>
             </a:pPr>
             <a:r>
-              <a:rPr lang="en-US" sz="3400" b="1" dirty="0">
+              <a:rPr lang="en-US" sz="2800" b="1" dirty="0">
                 <a:solidFill>
                   <a:srgbClr val="C9A24B"/>
                 </a:solidFill>
@@ -5082,9 +5082,9 @@
                 <a:ea typeface="Georgia" pitchFamily="34" charset="-122"/>
                 <a:cs typeface="Georgia" pitchFamily="34" charset="-120"/>
               </a:rPr>
-              <a:t>40 %</a:t>
-            </a:r>
-            <a:endParaRPr lang="en-US" sz="3400" dirty="0"/>
+              <a:t>38 %</a:t>
+            </a:r>
+            <a:endParaRPr lang="en-US" sz="2800" dirty="0"/>
           </a:p>
         </p:txBody>
       </p:sp>
@@ -5096,8 +5096,8 @@
         </p:nvSpPr>
         <p:spPr>
           <a:xfrm>
-            <a:off x="868680" y="5093208"/>
-            <a:ext cx="2377440" cy="320040"/>
+            <a:off x="804672" y="4773168"/>
+            <a:ext cx="2011680" cy="292608"/>
           </a:xfrm>
           <a:prstGeom prst="rect">
             <a:avLst/>
@@ -5113,7 +5113,7 @@
               <a:buNone/>
             </a:pPr>
             <a:r>
-              <a:rPr lang="en-US" sz="1200" b="1" dirty="0">
+              <a:rPr lang="en-US" sz="1100" b="1" dirty="0">
                 <a:solidFill>
                   <a:srgbClr val="F5EFE6"/>
                 </a:solidFill>
@@ -5121,9 +5121,9 @@
                 <a:ea typeface="Calibri" pitchFamily="34" charset="-122"/>
                 <a:cs typeface="Calibri" pitchFamily="34" charset="-120"/>
               </a:rPr>
-              <a:t>Team-Aufbau</a:t>
-            </a:r>
-            <a:endParaRPr lang="en-US" sz="1200" dirty="0"/>
+              <a:t>Team (4 Hires)</a:t>
+            </a:r>
+            <a:endParaRPr lang="en-US" sz="1100" dirty="0"/>
           </a:p>
         </p:txBody>
       </p:sp>
@@ -5135,8 +5135,8 @@
         </p:nvSpPr>
         <p:spPr>
           <a:xfrm>
-            <a:off x="868680" y="5376672"/>
-            <a:ext cx="2377440" cy="320040"/>
+            <a:off x="804672" y="5047488"/>
+            <a:ext cx="2011680" cy="365760"/>
           </a:xfrm>
           <a:prstGeom prst="rect">
             <a:avLst/>
@@ -5152,7 +5152,7 @@
               <a:buNone/>
             </a:pPr>
             <a:r>
-              <a:rPr lang="en-US" sz="1000" dirty="0">
+              <a:rPr lang="en-US" sz="850" dirty="0">
                 <a:solidFill>
                   <a:srgbClr val="8A7F6E"/>
                 </a:solidFill>
@@ -5160,9 +5160,9 @@
                 <a:ea typeface="Calibri" pitchFamily="34" charset="-122"/>
                 <a:cs typeface="Calibri" pitchFamily="34" charset="-120"/>
               </a:rPr>
-              <a:t>Ops, Care, Growth, Partner</a:t>
-            </a:r>
-            <a:endParaRPr lang="en-US" sz="1000" dirty="0"/>
+              <a:t>Head of Ops, 2× Care-Mgr, Growth, Partner</a:t>
+            </a:r>
+            <a:endParaRPr lang="en-US" sz="850" dirty="0"/>
           </a:p>
         </p:txBody>
       </p:sp>
@@ -5174,8 +5174,8 @@
         </p:nvSpPr>
         <p:spPr>
           <a:xfrm>
-            <a:off x="3584448" y="3611880"/>
-            <a:ext cx="2651760" cy="2103120"/>
+            <a:off x="3026664" y="3474720"/>
+            <a:ext cx="2157984" cy="1965960"/>
           </a:xfrm>
           <a:prstGeom prst="rect">
             <a:avLst/>
@@ -5207,8 +5207,8 @@
         </p:blipFill>
         <p:spPr>
           <a:xfrm>
-            <a:off x="4636008" y="3886200"/>
-            <a:ext cx="548640" cy="548640"/>
+            <a:off x="3867912" y="3675888"/>
+            <a:ext cx="475488" cy="475488"/>
           </a:xfrm>
           <a:prstGeom prst="rect">
             <a:avLst/>
@@ -5223,8 +5223,8 @@
         </p:nvSpPr>
         <p:spPr>
           <a:xfrm>
-            <a:off x="3584448" y="4526280"/>
-            <a:ext cx="2651760" cy="548640"/>
+            <a:off x="3026664" y="4251960"/>
+            <a:ext cx="2157984" cy="502920"/>
           </a:xfrm>
           <a:prstGeom prst="rect">
             <a:avLst/>
@@ -5240,7 +5240,7 @@
               <a:buNone/>
             </a:pPr>
             <a:r>
-              <a:rPr lang="en-US" sz="3400" b="1" dirty="0">
+              <a:rPr lang="en-US" sz="2800" b="1" dirty="0">
                 <a:solidFill>
                   <a:srgbClr val="C9A24B"/>
                 </a:solidFill>
@@ -5248,9 +5248,9 @@
                 <a:ea typeface="Georgia" pitchFamily="34" charset="-122"/>
                 <a:cs typeface="Georgia" pitchFamily="34" charset="-120"/>
               </a:rPr>
-              <a:t>30 %</a:t>
-            </a:r>
-            <a:endParaRPr lang="en-US" sz="3400" dirty="0"/>
+              <a:t>22 %</a:t>
+            </a:r>
+            <a:endParaRPr lang="en-US" sz="2800" dirty="0"/>
           </a:p>
         </p:txBody>
       </p:sp>
@@ -5262,8 +5262,8 @@
         </p:nvSpPr>
         <p:spPr>
           <a:xfrm>
-            <a:off x="3721608" y="5093208"/>
-            <a:ext cx="2377440" cy="320040"/>
+            <a:off x="3099816" y="4773168"/>
+            <a:ext cx="2011680" cy="292608"/>
           </a:xfrm>
           <a:prstGeom prst="rect">
             <a:avLst/>
@@ -5279,7 +5279,7 @@
               <a:buNone/>
             </a:pPr>
             <a:r>
-              <a:rPr lang="en-US" sz="1200" b="1" dirty="0">
+              <a:rPr lang="en-US" sz="1100" b="1" dirty="0">
                 <a:solidFill>
                   <a:srgbClr val="F5EFE6"/>
                 </a:solidFill>
@@ -5289,7 +5289,7 @@
               </a:rPr>
               <a:t>Marketing &amp; CAC</a:t>
             </a:r>
-            <a:endParaRPr lang="en-US" sz="1200" dirty="0"/>
+            <a:endParaRPr lang="en-US" sz="1100" dirty="0"/>
           </a:p>
         </p:txBody>
       </p:sp>
@@ -5301,8 +5301,8 @@
         </p:nvSpPr>
         <p:spPr>
           <a:xfrm>
-            <a:off x="3721608" y="5376672"/>
-            <a:ext cx="2377440" cy="320040"/>
+            <a:off x="3099816" y="5047488"/>
+            <a:ext cx="2011680" cy="365760"/>
           </a:xfrm>
           <a:prstGeom prst="rect">
             <a:avLst/>
@@ -5318,7 +5318,7 @@
               <a:buNone/>
             </a:pPr>
             <a:r>
-              <a:rPr lang="en-US" sz="1000" dirty="0">
+              <a:rPr lang="en-US" sz="850" dirty="0">
                 <a:solidFill>
                   <a:srgbClr val="8A7F6E"/>
                 </a:solidFill>
@@ -5326,9 +5326,9 @@
                 <a:ea typeface="Calibri" pitchFamily="34" charset="-122"/>
                 <a:cs typeface="Calibri" pitchFamily="34" charset="-120"/>
               </a:rPr>
-              <a:t>Paid Social, TV-regional, SEO</a:t>
-            </a:r>
-            <a:endParaRPr lang="en-US" sz="1000" dirty="0"/>
+              <a:t>Paid Social, SEO, Apotheken, PR</a:t>
+            </a:r>
+            <a:endParaRPr lang="en-US" sz="850" dirty="0"/>
           </a:p>
         </p:txBody>
       </p:sp>
@@ -5340,8 +5340,8 @@
         </p:nvSpPr>
         <p:spPr>
           <a:xfrm>
-            <a:off x="6437376" y="3611880"/>
-            <a:ext cx="2651760" cy="2103120"/>
+            <a:off x="5321808" y="3474720"/>
+            <a:ext cx="2157984" cy="1965960"/>
           </a:xfrm>
           <a:prstGeom prst="rect">
             <a:avLst/>
@@ -5373,8 +5373,8 @@
         </p:blipFill>
         <p:spPr>
           <a:xfrm>
-            <a:off x="7488936" y="3886200"/>
-            <a:ext cx="548640" cy="548640"/>
+            <a:off x="6163056" y="3675888"/>
+            <a:ext cx="475488" cy="475488"/>
           </a:xfrm>
           <a:prstGeom prst="rect">
             <a:avLst/>
@@ -5389,8 +5389,8 @@
         </p:nvSpPr>
         <p:spPr>
           <a:xfrm>
-            <a:off x="6437376" y="4526280"/>
-            <a:ext cx="2651760" cy="548640"/>
+            <a:off x="5321808" y="4251960"/>
+            <a:ext cx="2157984" cy="502920"/>
           </a:xfrm>
           <a:prstGeom prst="rect">
             <a:avLst/>
@@ -5406,7 +5406,7 @@
               <a:buNone/>
             </a:pPr>
             <a:r>
-              <a:rPr lang="en-US" sz="3400" b="1" dirty="0">
+              <a:rPr lang="en-US" sz="2800" b="1" dirty="0">
                 <a:solidFill>
                   <a:srgbClr val="C9A24B"/>
                 </a:solidFill>
@@ -5414,9 +5414,9 @@
                 <a:ea typeface="Georgia" pitchFamily="34" charset="-122"/>
                 <a:cs typeface="Georgia" pitchFamily="34" charset="-120"/>
               </a:rPr>
-              <a:t>20 %</a:t>
-            </a:r>
-            <a:endParaRPr lang="en-US" sz="3400" dirty="0"/>
+              <a:t>11 %</a:t>
+            </a:r>
+            <a:endParaRPr lang="en-US" sz="2800" dirty="0"/>
           </a:p>
         </p:txBody>
       </p:sp>
@@ -5428,8 +5428,8 @@
         </p:nvSpPr>
         <p:spPr>
           <a:xfrm>
-            <a:off x="6574536" y="5093208"/>
-            <a:ext cx="2377440" cy="320040"/>
+            <a:off x="5394960" y="4773168"/>
+            <a:ext cx="2011680" cy="292608"/>
           </a:xfrm>
           <a:prstGeom prst="rect">
             <a:avLst/>
@@ -5445,7 +5445,7 @@
               <a:buNone/>
             </a:pPr>
             <a:r>
-              <a:rPr lang="en-US" sz="1200" b="1" dirty="0">
+              <a:rPr lang="en-US" sz="1100" b="1" dirty="0">
                 <a:solidFill>
                   <a:srgbClr val="F5EFE6"/>
                 </a:solidFill>
@@ -5453,9 +5453,9 @@
                 <a:ea typeface="Calibri" pitchFamily="34" charset="-122"/>
                 <a:cs typeface="Calibri" pitchFamily="34" charset="-120"/>
               </a:rPr>
-              <a:t>Expansion NRW</a:t>
-            </a:r>
-            <a:endParaRPr lang="en-US" sz="1200" dirty="0"/>
+              <a:t>Gründer-Gehalt</a:t>
+            </a:r>
+            <a:endParaRPr lang="en-US" sz="1100" dirty="0"/>
           </a:p>
         </p:txBody>
       </p:sp>
@@ -5467,8 +5467,8 @@
         </p:nvSpPr>
         <p:spPr>
           <a:xfrm>
-            <a:off x="6574536" y="5376672"/>
-            <a:ext cx="2377440" cy="320040"/>
+            <a:off x="5394960" y="5047488"/>
+            <a:ext cx="2011680" cy="365760"/>
           </a:xfrm>
           <a:prstGeom prst="rect">
             <a:avLst/>
@@ -5484,7 +5484,7 @@
               <a:buNone/>
             </a:pPr>
             <a:r>
-              <a:rPr lang="en-US" sz="1000" dirty="0">
+              <a:rPr lang="en-US" sz="850" dirty="0">
                 <a:solidFill>
                   <a:srgbClr val="8A7F6E"/>
                 </a:solidFill>
@@ -5492,9 +5492,9 @@
                 <a:ea typeface="Calibri" pitchFamily="34" charset="-122"/>
                 <a:cs typeface="Calibri" pitchFamily="34" charset="-120"/>
               </a:rPr>
-              <a:t>Köln + Düsseldorf Launches</a:t>
-            </a:r>
-            <a:endParaRPr lang="en-US" sz="1000" dirty="0"/>
+              <a:t>Yusuf F. Demir, CEO/CTO · 6 T€/Mon brutto</a:t>
+            </a:r>
+            <a:endParaRPr lang="en-US" sz="850" dirty="0"/>
           </a:p>
         </p:txBody>
       </p:sp>
@@ -5506,8 +5506,8 @@
         </p:nvSpPr>
         <p:spPr>
           <a:xfrm>
-            <a:off x="9290304" y="3611880"/>
-            <a:ext cx="2651760" cy="2103120"/>
+            <a:off x="7616952" y="3474720"/>
+            <a:ext cx="2157984" cy="1965960"/>
           </a:xfrm>
           <a:prstGeom prst="rect">
             <a:avLst/>
@@ -5539,8 +5539,8 @@
         </p:blipFill>
         <p:spPr>
           <a:xfrm>
-            <a:off x="10341864" y="3886200"/>
-            <a:ext cx="548640" cy="548640"/>
+            <a:off x="8458200" y="3675888"/>
+            <a:ext cx="475488" cy="475488"/>
           </a:xfrm>
           <a:prstGeom prst="rect">
             <a:avLst/>
@@ -5555,8 +5555,8 @@
         </p:nvSpPr>
         <p:spPr>
           <a:xfrm>
-            <a:off x="9290304" y="4526280"/>
-            <a:ext cx="2651760" cy="548640"/>
+            <a:off x="7616952" y="4251960"/>
+            <a:ext cx="2157984" cy="502920"/>
           </a:xfrm>
           <a:prstGeom prst="rect">
             <a:avLst/>
@@ -5572,7 +5572,7 @@
               <a:buNone/>
             </a:pPr>
             <a:r>
-              <a:rPr lang="en-US" sz="3400" b="1" dirty="0">
+              <a:rPr lang="en-US" sz="2800" b="1" dirty="0">
                 <a:solidFill>
                   <a:srgbClr val="C9A24B"/>
                 </a:solidFill>
@@ -5580,9 +5580,9 @@
                 <a:ea typeface="Georgia" pitchFamily="34" charset="-122"/>
                 <a:cs typeface="Georgia" pitchFamily="34" charset="-120"/>
               </a:rPr>
-              <a:t>10 %</a:t>
-            </a:r>
-            <a:endParaRPr lang="en-US" sz="3400" dirty="0"/>
+              <a:t>11 %</a:t>
+            </a:r>
+            <a:endParaRPr lang="en-US" sz="2800" dirty="0"/>
           </a:p>
         </p:txBody>
       </p:sp>
@@ -5594,8 +5594,8 @@
         </p:nvSpPr>
         <p:spPr>
           <a:xfrm>
-            <a:off x="9427464" y="5093208"/>
-            <a:ext cx="2377440" cy="320040"/>
+            <a:off x="7690104" y="4773168"/>
+            <a:ext cx="2011680" cy="292608"/>
           </a:xfrm>
           <a:prstGeom prst="rect">
             <a:avLst/>
@@ -5611,7 +5611,7 @@
               <a:buNone/>
             </a:pPr>
             <a:r>
-              <a:rPr lang="en-US" sz="1200" b="1" dirty="0">
+              <a:rPr lang="en-US" sz="1100" b="1" dirty="0">
                 <a:solidFill>
                   <a:srgbClr val="F5EFE6"/>
                 </a:solidFill>
@@ -5619,9 +5619,9 @@
                 <a:ea typeface="Calibri" pitchFamily="34" charset="-122"/>
                 <a:cs typeface="Calibri" pitchFamily="34" charset="-120"/>
               </a:rPr>
-              <a:t>Technologie &amp; Ops</a:t>
-            </a:r>
-            <a:endParaRPr lang="en-US" sz="1200" dirty="0"/>
+              <a:t>Expansion NRW</a:t>
+            </a:r>
+            <a:endParaRPr lang="en-US" sz="1100" dirty="0"/>
           </a:p>
         </p:txBody>
       </p:sp>
@@ -5633,8 +5633,8 @@
         </p:nvSpPr>
         <p:spPr>
           <a:xfrm>
-            <a:off x="9427464" y="5376672"/>
-            <a:ext cx="2377440" cy="320040"/>
+            <a:off x="7690104" y="5047488"/>
+            <a:ext cx="2011680" cy="365760"/>
           </a:xfrm>
           <a:prstGeom prst="rect">
             <a:avLst/>
@@ -5650,7 +5650,7 @@
               <a:buNone/>
             </a:pPr>
             <a:r>
-              <a:rPr lang="en-US" sz="1000" dirty="0">
+              <a:rPr lang="en-US" sz="850" dirty="0">
                 <a:solidFill>
                   <a:srgbClr val="8A7F6E"/>
                 </a:solidFill>
@@ -5658,54 +5658,40 @@
                 <a:ea typeface="Calibri" pitchFamily="34" charset="-122"/>
                 <a:cs typeface="Calibri" pitchFamily="34" charset="-120"/>
               </a:rPr>
-              <a:t>Abrechnungs-Engine, KI-Matching</a:t>
-            </a:r>
-            <a:endParaRPr lang="en-US" sz="1000" dirty="0"/>
-          </a:p>
-        </p:txBody>
-      </p:sp>
-      <p:sp>
-        <p:nvSpPr>
-          <p:cNvPr id="26" name="Text 20"/>
-          <p:cNvSpPr/>
-          <p:nvPr/>
-        </p:nvSpPr>
-        <p:spPr>
-          <a:xfrm>
-            <a:off x="731520" y="6126480"/>
-            <a:ext cx="10972800" cy="365760"/>
-          </a:xfrm>
-          <a:prstGeom prst="rect">
-            <a:avLst/>
-          </a:prstGeom>
-          <a:noFill/>
-          <a:ln/>
-        </p:spPr>
-        <p:txBody>
-          <a:bodyPr wrap="square" lIns="0" tIns="0" rIns="0" bIns="0" rtlCol="0" anchor="ctr"/>
-          <a:lstStyle/>
-          <a:p>
-            <a:pPr indent="0" marL="0">
-              <a:buNone/>
-            </a:pPr>
-            <a:r>
-              <a:rPr lang="en-US" sz="1200" spc="200" kern="0" dirty="0">
-                <a:solidFill>
-                  <a:srgbClr val="E0C687"/>
-                </a:solidFill>
-                <a:latin typeface="Calibri" pitchFamily="34" charset="0"/>
-                <a:ea typeface="Calibri" pitchFamily="34" charset="-122"/>
-                <a:cs typeface="Calibri" pitchFamily="34" charset="-120"/>
-              </a:rPr>
-              <a:t>Nach Seed: 1.900 Kunden · 2,6 Mio € Umsatz · Break-Even Q2/2028 · Series-A ready</a:t>
-            </a:r>
-            <a:endParaRPr lang="en-US" sz="1200" dirty="0"/>
-          </a:p>
-        </p:txBody>
+              <a:t>Köln Q1/27 + Düsseldorf Q3/27</a:t>
+            </a:r>
+            <a:endParaRPr lang="en-US" sz="850" dirty="0"/>
+          </a:p>
+        </p:txBody>
+      </p:sp>
+      <p:sp>
+        <p:nvSpPr>
+          <p:cNvPr id="26" name="Shape 20"/>
+          <p:cNvSpPr/>
+          <p:nvPr/>
+        </p:nvSpPr>
+        <p:spPr>
+          <a:xfrm>
+            <a:off x="9912096" y="3474720"/>
+            <a:ext cx="2157984" cy="1965960"/>
+          </a:xfrm>
+          <a:prstGeom prst="rect">
+            <a:avLst/>
+          </a:prstGeom>
+          <a:solidFill>
+            <a:srgbClr val="2A241D"/>
+          </a:solidFill>
+          <a:ln w="9525">
+            <a:solidFill>
+              <a:srgbClr val="C9A24B"/>
+            </a:solidFill>
+            <a:prstDash val="solid"/>
+          </a:ln>
+        </p:spPr>
       </p:sp>
       <p:pic>
         <p:nvPicPr>
-          <p:cNvPr id="27" name="Image 4" descr="logo-mark.png">    </p:cNvPr>
+          <p:cNvPr id="27" name="Image 4" descr="preencoded.png">    </p:cNvPr>
           <p:cNvPicPr>
             <a:picLocks noChangeAspect="1"/>
           </p:cNvPicPr>
@@ -5719,6 +5705,225 @@
         </p:blipFill>
         <p:spPr>
           <a:xfrm>
+            <a:off x="10753344" y="3675888"/>
+            <a:ext cx="475488" cy="475488"/>
+          </a:xfrm>
+          <a:prstGeom prst="rect">
+            <a:avLst/>
+          </a:prstGeom>
+        </p:spPr>
+      </p:pic>
+      <p:sp>
+        <p:nvSpPr>
+          <p:cNvPr id="28" name="Text 21"/>
+          <p:cNvSpPr/>
+          <p:nvPr/>
+        </p:nvSpPr>
+        <p:spPr>
+          <a:xfrm>
+            <a:off x="9912096" y="4251960"/>
+            <a:ext cx="2157984" cy="502920"/>
+          </a:xfrm>
+          <a:prstGeom prst="rect">
+            <a:avLst/>
+          </a:prstGeom>
+          <a:noFill/>
+          <a:ln/>
+        </p:spPr>
+        <p:txBody>
+          <a:bodyPr wrap="square" lIns="0" tIns="0" rIns="0" bIns="0" rtlCol="0" anchor="ctr"/>
+          <a:lstStyle/>
+          <a:p>
+            <a:pPr algn="ctr" indent="0" marL="0">
+              <a:buNone/>
+            </a:pPr>
+            <a:r>
+              <a:rPr lang="en-US" sz="2800" b="1" dirty="0">
+                <a:solidFill>
+                  <a:srgbClr val="C9A24B"/>
+                </a:solidFill>
+                <a:latin typeface="Georgia" pitchFamily="34" charset="0"/>
+                <a:ea typeface="Georgia" pitchFamily="34" charset="-122"/>
+                <a:cs typeface="Georgia" pitchFamily="34" charset="-120"/>
+              </a:rPr>
+              <a:t>18 %</a:t>
+            </a:r>
+            <a:endParaRPr lang="en-US" sz="2800" dirty="0"/>
+          </a:p>
+        </p:txBody>
+      </p:sp>
+      <p:sp>
+        <p:nvSpPr>
+          <p:cNvPr id="29" name="Text 22"/>
+          <p:cNvSpPr/>
+          <p:nvPr/>
+        </p:nvSpPr>
+        <p:spPr>
+          <a:xfrm>
+            <a:off x="9985248" y="4773168"/>
+            <a:ext cx="2011680" cy="292608"/>
+          </a:xfrm>
+          <a:prstGeom prst="rect">
+            <a:avLst/>
+          </a:prstGeom>
+          <a:noFill/>
+          <a:ln/>
+        </p:spPr>
+        <p:txBody>
+          <a:bodyPr wrap="square" lIns="0" tIns="0" rIns="0" bIns="0" rtlCol="0" anchor="ctr"/>
+          <a:lstStyle/>
+          <a:p>
+            <a:pPr algn="ctr" indent="0" marL="0">
+              <a:buNone/>
+            </a:pPr>
+            <a:r>
+              <a:rPr lang="en-US" sz="1100" b="1" dirty="0">
+                <a:solidFill>
+                  <a:srgbClr val="F5EFE6"/>
+                </a:solidFill>
+                <a:latin typeface="Calibri" pitchFamily="34" charset="0"/>
+                <a:ea typeface="Calibri" pitchFamily="34" charset="-122"/>
+                <a:cs typeface="Calibri" pitchFamily="34" charset="-120"/>
+              </a:rPr>
+              <a:t>Ops, Tech, Setup</a:t>
+            </a:r>
+            <a:endParaRPr lang="en-US" sz="1100" dirty="0"/>
+          </a:p>
+        </p:txBody>
+      </p:sp>
+      <p:sp>
+        <p:nvSpPr>
+          <p:cNvPr id="30" name="Text 23"/>
+          <p:cNvSpPr/>
+          <p:nvPr/>
+        </p:nvSpPr>
+        <p:spPr>
+          <a:xfrm>
+            <a:off x="9985248" y="5047488"/>
+            <a:ext cx="2011680" cy="365760"/>
+          </a:xfrm>
+          <a:prstGeom prst="rect">
+            <a:avLst/>
+          </a:prstGeom>
+          <a:noFill/>
+          <a:ln/>
+        </p:spPr>
+        <p:txBody>
+          <a:bodyPr wrap="square" lIns="0" tIns="0" rIns="0" bIns="0" rtlCol="0" anchor="ctr"/>
+          <a:lstStyle/>
+          <a:p>
+            <a:pPr algn="ctr" indent="0" marL="0">
+              <a:buNone/>
+            </a:pPr>
+            <a:r>
+              <a:rPr lang="en-US" sz="850" dirty="0">
+                <a:solidFill>
+                  <a:srgbClr val="8A7F6E"/>
+                </a:solidFill>
+                <a:latin typeface="Calibri" pitchFamily="34" charset="0"/>
+                <a:ea typeface="Calibri" pitchFamily="34" charset="-122"/>
+                <a:cs typeface="Calibri" pitchFamily="34" charset="-120"/>
+              </a:rPr>
+              <a:t>Tech · Büro · Auto · Recht · Puffer</a:t>
+            </a:r>
+            <a:endParaRPr lang="en-US" sz="850" dirty="0"/>
+          </a:p>
+        </p:txBody>
+      </p:sp>
+      <p:sp>
+        <p:nvSpPr>
+          <p:cNvPr id="31" name="Text 24"/>
+          <p:cNvSpPr/>
+          <p:nvPr/>
+        </p:nvSpPr>
+        <p:spPr>
+          <a:xfrm>
+            <a:off x="731520" y="5577840"/>
+            <a:ext cx="11338560" cy="320040"/>
+          </a:xfrm>
+          <a:prstGeom prst="rect">
+            <a:avLst/>
+          </a:prstGeom>
+          <a:noFill/>
+          <a:ln/>
+        </p:spPr>
+        <p:txBody>
+          <a:bodyPr wrap="square" lIns="0" tIns="0" rIns="0" bIns="0" rtlCol="0" anchor="ctr"/>
+          <a:lstStyle/>
+          <a:p>
+            <a:pPr algn="ctr" indent="0" marL="0">
+              <a:buNone/>
+            </a:pPr>
+            <a:r>
+              <a:rPr lang="en-US" sz="950" dirty="0">
+                <a:solidFill>
+                  <a:srgbClr val="E0C687"/>
+                </a:solidFill>
+                <a:latin typeface="Calibri" pitchFamily="34" charset="0"/>
+                <a:ea typeface="Calibri" pitchFamily="34" charset="-122"/>
+                <a:cs typeface="Calibri" pitchFamily="34" charset="-120"/>
+              </a:rPr>
+              <a:t>Detail Ops-Bucket:  Tech &amp; Infrastruktur 6,0 %  ·  Recht/Notar/Versicherung 3,2 %  ·  Büro &amp; Co-Working 2,2 %  ·  Firmenwagen 1,8 %  ·  Puffer 5,0 %</a:t>
+            </a:r>
+            <a:endParaRPr lang="en-US" sz="950" dirty="0"/>
+          </a:p>
+        </p:txBody>
+      </p:sp>
+      <p:sp>
+        <p:nvSpPr>
+          <p:cNvPr id="32" name="Text 25"/>
+          <p:cNvSpPr/>
+          <p:nvPr/>
+        </p:nvSpPr>
+        <p:spPr>
+          <a:xfrm>
+            <a:off x="731520" y="5989320"/>
+            <a:ext cx="10972800" cy="365760"/>
+          </a:xfrm>
+          <a:prstGeom prst="rect">
+            <a:avLst/>
+          </a:prstGeom>
+          <a:noFill/>
+          <a:ln/>
+        </p:spPr>
+        <p:txBody>
+          <a:bodyPr wrap="square" lIns="0" tIns="0" rIns="0" bIns="0" rtlCol="0" anchor="ctr"/>
+          <a:lstStyle/>
+          <a:p>
+            <a:pPr indent="0" marL="0">
+              <a:buNone/>
+            </a:pPr>
+            <a:r>
+              <a:rPr lang="en-US" sz="1200" spc="200" kern="0" dirty="0">
+                <a:solidFill>
+                  <a:srgbClr val="E0C687"/>
+                </a:solidFill>
+                <a:latin typeface="Calibri" pitchFamily="34" charset="0"/>
+                <a:ea typeface="Calibri" pitchFamily="34" charset="-122"/>
+                <a:cs typeface="Calibri" pitchFamily="34" charset="-120"/>
+              </a:rPr>
+              <a:t>Nach Seed: 1.900 Kunden · 2,6 Mio € Umsatz · Break-Even Q2/2028 · Series-A ready</a:t>
+            </a:r>
+            <a:endParaRPr lang="en-US" sz="1200" dirty="0"/>
+          </a:p>
+        </p:txBody>
+      </p:sp>
+      <p:pic>
+        <p:nvPicPr>
+          <p:cNvPr id="33" name="Image 5" descr="logo-mark.png">    </p:cNvPr>
+          <p:cNvPicPr>
+            <a:picLocks noChangeAspect="1"/>
+          </p:cNvPicPr>
+          <p:nvPr/>
+        </p:nvPicPr>
+        <p:blipFill>
+          <a:blip r:embed="rId6"/>
+          <a:stretch>
+            <a:fillRect/>
+          </a:stretch>
+        </p:blipFill>
+        <p:spPr>
+          <a:xfrm>
             <a:off x="11002975" y="274320"/>
             <a:ext cx="777240" cy="429768"/>
           </a:xfrm>
@@ -5729,7 +5934,7 @@
       </p:pic>
       <p:sp>
         <p:nvSpPr>
-          <p:cNvPr id="28" name="Shape 21"/>
+          <p:cNvPr id="34" name="Shape 26"/>
           <p:cNvSpPr/>
           <p:nvPr/>
         </p:nvSpPr>
@@ -5749,7 +5954,7 @@
       </p:sp>
       <p:sp>
         <p:nvSpPr>
-          <p:cNvPr id="29" name="Text 22"/>
+          <p:cNvPr id="35" name="Text 27"/>
           <p:cNvSpPr/>
           <p:nvPr/>
         </p:nvSpPr>
@@ -5788,7 +5993,7 @@
       </p:sp>
       <p:sp>
         <p:nvSpPr>
-          <p:cNvPr id="30" name="Text 23"/>
+          <p:cNvPr id="36" name="Text 28"/>
           <p:cNvSpPr/>
           <p:nvPr/>
         </p:nvSpPr>

</xml_diff>

<commit_message>
fix: Test-Engel (is_test=true) aus Kunden-Matching ausschließen (3 Stellen: karte, home, buchen-service)
Co-Authored-By: Claude Opus 4.7 (1M context) <noreply@anthropic.com>
</commit_message>
<xml_diff>
--- a/investor/AlltagsEngel_PitchDeck_2026.pptx
+++ b/investor/AlltagsEngel_PitchDeck_2026.pptx
@@ -4955,7 +4955,7 @@
                 <a:ea typeface="Georgia" pitchFamily="34" charset="-122"/>
                 <a:cs typeface="Georgia" pitchFamily="34" charset="-120"/>
               </a:rPr>
-              <a:t>1,0 Mio €</a:t>
+              <a:t>1,5 Mio €</a:t>
             </a:r>
             <a:endParaRPr lang="en-US" sz="9600" dirty="0"/>
           </a:p>
@@ -4986,7 +4986,7 @@
               <a:buNone/>
             </a:pPr>
             <a:r>
-              <a:rPr lang="en-US" sz="1600" spc="200" kern="0" dirty="0">
+              <a:rPr lang="en-US" sz="1400" spc="100" kern="0" dirty="0">
                 <a:solidFill>
                   <a:srgbClr val="E0C687"/>
                 </a:solidFill>
@@ -4994,9 +4994,9 @@
                 <a:ea typeface="Calibri" pitchFamily="34" charset="-122"/>
                 <a:cs typeface="Calibri" pitchFamily="34" charset="-120"/>
               </a:rPr>
-              <a:t>Pre-Seed · Wandeldarlehen oder Equity · 18–24 Monate Runway</a:t>
-            </a:r>
-            <a:endParaRPr lang="en-US" sz="1600" dirty="0"/>
+              <a:t>Pre-Seed · 25 % Equity · Pre-Money 4,5 Mio € · 27 Monate Runway bis Profitabilität</a:t>
+            </a:r>
+            <a:endParaRPr lang="en-US" sz="1400" dirty="0"/>
           </a:p>
         </p:txBody>
       </p:sp>
@@ -5121,7 +5121,7 @@
                 <a:ea typeface="Calibri" pitchFamily="34" charset="-122"/>
                 <a:cs typeface="Calibri" pitchFamily="34" charset="-120"/>
               </a:rPr>
-              <a:t>Team (4 Hires)</a:t>
+              <a:t>Team (5 Hires)</a:t>
             </a:r>
             <a:endParaRPr lang="en-US" sz="1100" dirty="0"/>
           </a:p>
@@ -5160,7 +5160,7 @@
                 <a:ea typeface="Calibri" pitchFamily="34" charset="-122"/>
                 <a:cs typeface="Calibri" pitchFamily="34" charset="-120"/>
               </a:rPr>
-              <a:t>Head of Ops, 2× Care-Mgr, Growth, Partner</a:t>
+              <a:t>Head of Ops, 2× Care-Mgr, Growth, Partner-Mgr</a:t>
             </a:r>
             <a:endParaRPr lang="en-US" sz="850" dirty="0"/>
           </a:p>
@@ -5580,7 +5580,7 @@
                 <a:ea typeface="Georgia" pitchFamily="34" charset="-122"/>
                 <a:cs typeface="Georgia" pitchFamily="34" charset="-120"/>
               </a:rPr>
-              <a:t>11 %</a:t>
+              <a:t>13 %</a:t>
             </a:r>
             <a:endParaRPr lang="en-US" sz="2800" dirty="0"/>
           </a:p>
@@ -5619,7 +5619,7 @@
                 <a:ea typeface="Calibri" pitchFamily="34" charset="-122"/>
                 <a:cs typeface="Calibri" pitchFamily="34" charset="-120"/>
               </a:rPr>
-              <a:t>Expansion NRW</a:t>
+              <a:t>Expansion DE</a:t>
             </a:r>
             <a:endParaRPr lang="en-US" sz="1100" dirty="0"/>
           </a:p>
@@ -5658,7 +5658,7 @@
                 <a:ea typeface="Calibri" pitchFamily="34" charset="-122"/>
                 <a:cs typeface="Calibri" pitchFamily="34" charset="-120"/>
               </a:rPr>
-              <a:t>Köln Q1/27 + Düsseldorf Q3/27</a:t>
+              <a:t>Köln Q1/27 · Düsseldorf Q3/27 · Berlin Q2/28</a:t>
             </a:r>
             <a:endParaRPr lang="en-US" sz="850" dirty="0"/>
           </a:p>
@@ -5746,7 +5746,7 @@
                 <a:ea typeface="Georgia" pitchFamily="34" charset="-122"/>
                 <a:cs typeface="Georgia" pitchFamily="34" charset="-120"/>
               </a:rPr>
-              <a:t>18 %</a:t>
+              <a:t>16 %</a:t>
             </a:r>
             <a:endParaRPr lang="en-US" sz="2800" dirty="0"/>
           </a:p>
@@ -5863,7 +5863,7 @@
                 <a:ea typeface="Calibri" pitchFamily="34" charset="-122"/>
                 <a:cs typeface="Calibri" pitchFamily="34" charset="-120"/>
               </a:rPr>
-              <a:t>Detail Ops-Bucket:  Tech &amp; Infrastruktur 6,0 %  ·  Recht/Notar/Versicherung 3,2 %  ·  Büro &amp; Co-Working 2,2 %  ·  Firmenwagen 1,8 %  ·  Puffer 5,0 %</a:t>
+              <a:t>Detail Ops-Bucket:  Tech &amp; Infrastruktur 5,5 %  ·  Recht/Notar/Versicherung 3,0 %  ·  Büro &amp; Co-Working 2,0 %  ·  Firmenwagen 1,5 %  ·  Puffer 4,0 %</a:t>
             </a:r>
             <a:endParaRPr lang="en-US" sz="950" dirty="0"/>
           </a:p>
@@ -5894,7 +5894,7 @@
               <a:buNone/>
             </a:pPr>
             <a:r>
-              <a:rPr lang="en-US" sz="1200" spc="200" kern="0" dirty="0">
+              <a:rPr lang="en-US" sz="1200" spc="100" kern="0" dirty="0">
                 <a:solidFill>
                   <a:srgbClr val="E0C687"/>
                 </a:solidFill>
@@ -5902,7 +5902,7 @@
                 <a:ea typeface="Calibri" pitchFamily="34" charset="-122"/>
                 <a:cs typeface="Calibri" pitchFamily="34" charset="-120"/>
               </a:rPr>
-              <a:t>Nach Seed: 1.900 Kunden · 2,6 Mio € Umsatz · Break-Even Q2/2028 · Series-A ready</a:t>
+              <a:t>1,5 Mio bringt uns BIS ZUR PROFITABILITÄT (Q3/2028) — keine zweite Runde nötig, keine Verwässerung für PROLIFE</a:t>
             </a:r>
             <a:endParaRPr lang="en-US" sz="1200" dirty="0"/>
           </a:p>

</xml_diff>